<commit_message>
Preserve chart aspect ratios in vLLM deck
Co-authored-by: laodie <shenlongld@users.noreply.github.com>
</commit_message>
<xml_diff>
--- a/vLLM框架推理流程及其性能增益可视化分析.pptx
+++ b/vLLM框架推理流程及其性能增益可视化分析.pptx
@@ -3240,8 +3240,8 @@
         </p:blipFill>
         <p:spPr>
           <a:xfrm>
-            <a:off x="301752" y="877824"/>
-            <a:ext cx="7635240" cy="5596128"/>
+            <a:off x="301752" y="1204123"/>
+            <a:ext cx="7635240" cy="4943529"/>
           </a:xfrm>
           <a:prstGeom prst="rect">
             <a:avLst/>
@@ -3592,8 +3592,8 @@
         </p:blipFill>
         <p:spPr>
           <a:xfrm>
-            <a:off x="301752" y="877824"/>
-            <a:ext cx="7635240" cy="5596128"/>
+            <a:off x="301752" y="1546116"/>
+            <a:ext cx="7635240" cy="4259544"/>
           </a:xfrm>
           <a:prstGeom prst="rect">
             <a:avLst/>
@@ -4006,8 +4006,8 @@
         </p:blipFill>
         <p:spPr>
           <a:xfrm>
-            <a:off x="301752" y="877824"/>
-            <a:ext cx="7635240" cy="5596128"/>
+            <a:off x="301752" y="1251785"/>
+            <a:ext cx="7635240" cy="4848206"/>
           </a:xfrm>
           <a:prstGeom prst="rect">
             <a:avLst/>
@@ -4420,8 +4420,8 @@
         </p:blipFill>
         <p:spPr>
           <a:xfrm>
-            <a:off x="301752" y="877824"/>
-            <a:ext cx="7635240" cy="5596128"/>
+            <a:off x="301752" y="1449467"/>
+            <a:ext cx="7635240" cy="4452841"/>
           </a:xfrm>
           <a:prstGeom prst="rect">
             <a:avLst/>
@@ -4834,8 +4834,8 @@
         </p:blipFill>
         <p:spPr>
           <a:xfrm>
-            <a:off x="301752" y="877824"/>
-            <a:ext cx="7635240" cy="5596128"/>
+            <a:off x="301752" y="1227632"/>
+            <a:ext cx="7635240" cy="4896512"/>
           </a:xfrm>
           <a:prstGeom prst="rect">
             <a:avLst/>
@@ -5217,8 +5217,8 @@
         </p:blipFill>
         <p:spPr>
           <a:xfrm>
-            <a:off x="301752" y="877824"/>
-            <a:ext cx="7635240" cy="5596128"/>
+            <a:off x="301752" y="1374306"/>
+            <a:ext cx="7635240" cy="4603163"/>
           </a:xfrm>
           <a:prstGeom prst="rect">
             <a:avLst/>
@@ -5600,8 +5600,8 @@
         </p:blipFill>
         <p:spPr>
           <a:xfrm>
-            <a:off x="301752" y="877824"/>
-            <a:ext cx="7635240" cy="5596128"/>
+            <a:off x="301752" y="1519771"/>
+            <a:ext cx="7635240" cy="4312233"/>
           </a:xfrm>
           <a:prstGeom prst="rect">
             <a:avLst/>
@@ -5983,8 +5983,8 @@
         </p:blipFill>
         <p:spPr>
           <a:xfrm>
-            <a:off x="301752" y="877824"/>
-            <a:ext cx="7635240" cy="5596128"/>
+            <a:off x="1607876" y="877824"/>
+            <a:ext cx="5022991" cy="5596128"/>
           </a:xfrm>
           <a:prstGeom prst="rect">
             <a:avLst/>

</xml_diff>

<commit_message>
Enhance memory mapping visuals in vLLM deck
Co-authored-by: laodie <shenlongld@users.noreply.github.com>
</commit_message>
<xml_diff>
--- a/vLLM框架推理流程及其性能增益可视化分析.pptx
+++ b/vLLM框架推理流程及其性能增益可视化分析.pptx
@@ -4006,8 +4006,8 @@
         </p:blipFill>
         <p:spPr>
           <a:xfrm>
-            <a:off x="301752" y="1251785"/>
-            <a:ext cx="7635240" cy="4848206"/>
+            <a:off x="302013" y="877824"/>
+            <a:ext cx="7634717" cy="5596128"/>
           </a:xfrm>
           <a:prstGeom prst="rect">
             <a:avLst/>
@@ -4420,8 +4420,8 @@
         </p:blipFill>
         <p:spPr>
           <a:xfrm>
-            <a:off x="301752" y="1449467"/>
-            <a:ext cx="7635240" cy="4452841"/>
+            <a:off x="302013" y="877824"/>
+            <a:ext cx="7634717" cy="5596128"/>
           </a:xfrm>
           <a:prstGeom prst="rect">
             <a:avLst/>
@@ -4834,8 +4834,8 @@
         </p:blipFill>
         <p:spPr>
           <a:xfrm>
-            <a:off x="301752" y="1227632"/>
-            <a:ext cx="7635240" cy="4896512"/>
+            <a:off x="302013" y="877824"/>
+            <a:ext cx="7634717" cy="5596128"/>
           </a:xfrm>
           <a:prstGeom prst="rect">
             <a:avLst/>

</xml_diff>